<commit_message>
Back the FinancialBERT bake-off claim with a measured artifact
The 96.7% figure circulated in commit messages and notes without a
committed evaluation to point at. Ran the identical held-out split
(483 rows, seed 42) through the shipped model locally and committed
the result: 96.69% accuracy, 0.9661 macro F1
(docs/evidence/financialbert_eval.json).

Synced every consumer of the old numbers to the final evidence:
sentiment_metrics bake-off table, README key results, and the deck
(hit rate 56.2%, credit CAR +24.9bps t=2.96, impact IC 0.098 with
the adopted VIX regime factor, vol-targeted -10.4% @ 20.7%).
</commit_message>
<xml_diff>
--- a/docs/presentation.pptx
+++ b/docs/presentation.pptx
@@ -1959,7 +1959,7 @@
                 <a:ea typeface="Segoe UI" pitchFamily="34" charset="-122"/>
                 <a:cs typeface="Segoe UI" pitchFamily="34" charset="-120"/>
               </a:rPr>
-              <a:t>Specialist models where they win: FinBERT for calibrated sentiment, a small LLM for per-entity understanding.</a:t>
+              <a:t>Specialist models where they win: FinancialBERT for calibrated sentiment, a small LLM for per-entity understanding.</a:t>
             </a:r>
             <a:endParaRPr lang="en-US" sz="1400" dirty="0"/>
           </a:p>
@@ -2183,7 +2183,7 @@
                 <a:ea typeface="Segoe UI" pitchFamily="34" charset="-122"/>
                 <a:cs typeface="Segoe UI" pitchFamily="34" charset="-120"/>
               </a:rPr>
-              <a:t>FinBERT, 89.4% held-out accuracy</a:t>
+              <a:t>FinancialBERT, 96.7% held-out accuracy</a:t>
             </a:r>
             <a:endParaRPr lang="en-US" sz="1150" dirty="0"/>
           </a:p>
@@ -2855,7 +2855,7 @@
                 <a:ea typeface="Segoe UI" pitchFamily="34" charset="-122"/>
                 <a:cs typeface="Segoe UI" pitchFamily="34" charset="-120"/>
               </a:rPr>
-              <a:t>entity matcher (aliases + cashtags)  -&gt;  FinBERT sentiment [-1,1]  -&gt;  per-entity LLM layer (Qwen3-4B JSON)  -&gt;  event classifier  -&gt;  impact = severity x conviction x corroboration</a:t>
+              <a:t>entity matcher (aliases + cashtags)  -&gt;  FinancialBERT sentiment [-1,1]  -&gt;  per-entity LLM layer (Qwen3-4B JSON)  -&gt;  event classifier  -&gt;  impact = severity x conviction x corroboration</a:t>
             </a:r>
             <a:endParaRPr lang="en-US" sz="1250" dirty="0"/>
           </a:p>
@@ -3065,7 +3065,7 @@
                 <a:ea typeface="Segoe UI" pitchFamily="34" charset="-122"/>
                 <a:cs typeface="Segoe UI" pitchFamily="34" charset="-120"/>
               </a:rPr>
-              <a:t>FastAPI (14 endpoints, SQLite WAL) serves both the REST API and the React dashboard on one port.  46 tests green  ·  CI on every push  ·  resumable data pipelines</a:t>
+              <a:t>FastAPI (14 endpoints, SQLite WAL) serves both the REST API and the React dashboard on one port.  47 tests green  ·  CI on every push  ·  resumable data pipelines</a:t>
             </a:r>
             <a:endParaRPr lang="en-US" sz="1250" dirty="0"/>
           </a:p>
@@ -3241,7 +3241,7 @@
                 <a:ea typeface="Segoe UI" pitchFamily="34" charset="-122"/>
                 <a:cs typeface="Segoe UI" pitchFamily="34" charset="-120"/>
               </a:rPr>
-              <a:t>FinBERT for bulk sentiment</a:t>
+              <a:t>FinancialBERT for bulk sentiment</a:t>
             </a:r>
             <a:endParaRPr lang="en-US" sz="1500" dirty="0"/>
           </a:p>
@@ -3280,7 +3280,7 @@
                 <a:ea typeface="Segoe UI" pitchFamily="34" charset="-122"/>
                 <a:cs typeface="Segoe UI" pitchFamily="34" charset="-120"/>
               </a:rPr>
-              <a:t>89.4%</a:t>
+              <a:t>96.7%</a:t>
             </a:r>
             <a:endParaRPr lang="en-US" sz="2600" dirty="0"/>
           </a:p>
@@ -3358,7 +3358,7 @@
                 <a:ea typeface="Segoe UI" pitchFamily="34" charset="-122"/>
                 <a:cs typeface="Segoe UI" pitchFamily="34" charset="-120"/>
               </a:rPr>
-              <a:t>Best of 5 benchmarked models on the held-out split (89.4% vs 88.6-76.9%). 110M params, 30ms on CPU - runs on the jury's laptop.</a:t>
+              <a:t>Bake-off of 6 models on an identical held-out split: 96.7% vs 89.4% for base FinBERT. 110M params, 30ms on CPU - runs on the jury's laptop.</a:t>
             </a:r>
             <a:endParaRPr lang="en-US" sz="1200" dirty="0"/>
           </a:p>
@@ -4136,7 +4136,7 @@
                           <a:ea typeface="Segoe UI" pitchFamily="34" charset="-122"/>
                           <a:cs typeface="Segoe UI" pitchFamily="34" charset="-120"/>
                         </a:rPr>
-                        <a:t>89.4%</a:t>
+                        <a:t>96.7%</a:t>
                       </a:r>
                       <a:endParaRPr lang="en-US" sz="1500" dirty="0">
                         <a:latin typeface="Segoe UI" charset="0"/>
@@ -4204,7 +4204,7 @@
                           <a:ea typeface="Segoe UI" pitchFamily="34" charset="-122"/>
                           <a:cs typeface="Segoe UI" pitchFamily="34" charset="-120"/>
                         </a:rPr>
-                        <a:t>best of 5 benchmarked models</a:t>
+                        <a:t>bake-off of 6 models; base FinBERT 89.4%</a:t>
                       </a:r>
                       <a:endParaRPr lang="en-US" sz="1100" dirty="0">
                         <a:latin typeface="Segoe UI" charset="0"/>
@@ -4342,7 +4342,7 @@
                           <a:ea typeface="Segoe UI" pitchFamily="34" charset="-122"/>
                           <a:cs typeface="Segoe UI" pitchFamily="34" charset="-120"/>
                         </a:rPr>
-                        <a:t>55.6%</a:t>
+                        <a:t>56.2%</a:t>
                       </a:r>
                       <a:endParaRPr lang="en-US" sz="1500" dirty="0">
                         <a:latin typeface="Segoe UI" charset="0"/>
@@ -4410,7 +4410,7 @@
                           <a:ea typeface="Segoe UI" pitchFamily="34" charset="-122"/>
                           <a:cs typeface="Segoe UI" pitchFamily="34" charset="-120"/>
                         </a:rPr>
-                        <a:t>3,605 events; literature bar 53-55%</a:t>
+                        <a:t>strong-signal events; literature bar 53-55%</a:t>
                       </a:r>
                       <a:endParaRPr lang="en-US" sz="1100" dirty="0">
                         <a:latin typeface="Segoe UI" charset="0"/>
@@ -4548,7 +4548,7 @@
                           <a:ea typeface="Segoe UI" pitchFamily="34" charset="-122"/>
                           <a:cs typeface="Segoe UI" pitchFamily="34" charset="-120"/>
                         </a:rPr>
-                        <a:t>+25.2 bps</a:t>
+                        <a:t>+24.9 bps</a:t>
                       </a:r>
                       <a:endParaRPr lang="en-US" sz="1500" dirty="0">
                         <a:latin typeface="Segoe UI" charset="0"/>
@@ -4616,7 +4616,7 @@
                           <a:ea typeface="Segoe UI" pitchFamily="34" charset="-122"/>
                           <a:cs typeface="Segoe UI" pitchFamily="34" charset="-120"/>
                         </a:rPr>
-                        <a:t>t = 3.01, significant at 1%</a:t>
+                        <a:t>t = 2.96, significant at 1%</a:t>
                       </a:r>
                       <a:endParaRPr lang="en-US" sz="1100" dirty="0">
                         <a:latin typeface="Segoe UI" charset="0"/>
@@ -4754,7 +4754,7 @@
                           <a:ea typeface="Segoe UI" pitchFamily="34" charset="-122"/>
                           <a:cs typeface="Segoe UI" pitchFamily="34" charset="-120"/>
                         </a:rPr>
-                        <a:t>IC +0.066</a:t>
+                        <a:t>IC +0.098</a:t>
                       </a:r>
                       <a:endParaRPr lang="en-US" sz="1500" dirty="0">
                         <a:latin typeface="Segoe UI" charset="0"/>
@@ -4822,7 +4822,7 @@
                           <a:ea typeface="Segoe UI" pitchFamily="34" charset="-122"/>
                           <a:cs typeface="Segoe UI" pitchFamily="34" charset="-120"/>
                         </a:rPr>
-                        <a:t>19,872 real events</a:t>
+                        <a:t>calibrated severity + VIX regime; 19,872 events</a:t>
                       </a:r>
                       <a:endParaRPr lang="en-US" sz="1100" dirty="0">
                         <a:latin typeface="Segoe UI" charset="0"/>
@@ -5098,7 +5098,7 @@
                           <a:ea typeface="Segoe UI" pitchFamily="34" charset="-122"/>
                           <a:cs typeface="Segoe UI" pitchFamily="34" charset="-120"/>
                         </a:rPr>
-                        <a:t>Rebalancer vs cap-weight (2022 bear, net)</a:t>
+                        <a:t>Rebalancer vs cap-weight (2022 bear, net of costs)</a:t>
                       </a:r>
                       <a:endParaRPr lang="en-US" sz="1350" dirty="0">
                         <a:latin typeface="Segoe UI" charset="0"/>
@@ -5166,7 +5166,7 @@
                           <a:ea typeface="Segoe UI" pitchFamily="34" charset="-122"/>
                           <a:cs typeface="Segoe UI" pitchFamily="34" charset="-120"/>
                         </a:rPr>
-                        <a:t>+4.8 pts</a:t>
+                        <a:t>+0.9 pts</a:t>
                       </a:r>
                       <a:endParaRPr lang="en-US" sz="1500" dirty="0">
                         <a:latin typeface="Segoe UI" charset="0"/>
@@ -5234,7 +5234,213 @@
                           <a:ea typeface="Segoe UI" pitchFamily="34" charset="-122"/>
                           <a:cs typeface="Segoe UI" pitchFamily="34" charset="-120"/>
                         </a:rPr>
-                        <a:t>510-day walk-forward, 10bps costs</a:t>
+                        <a:t>look-ahead-free walk-forward, 352 days</a:t>
+                      </a:r>
+                      <a:endParaRPr lang="en-US" sz="1100" dirty="0">
+                        <a:latin typeface="Segoe UI" charset="0"/>
+                        <a:ea typeface="Segoe UI" charset="0"/>
+                        <a:cs typeface="Segoe UI" charset="0"/>
+                      </a:endParaRPr>
+                    </a:p>
+                  </a:txBody>
+                  <a:tcPr marL="91440" marR="91440" marT="45720" marB="45720" anchor="ctr">
+                    <a:lnL w="6350" cap="flat" cmpd="sng" algn="ctr">
+                      <a:solidFill>
+                        <a:srgbClr val="1B2C4D"/>
+                      </a:solidFill>
+                      <a:prstDash val="solid"/>
+                      <a:round/>
+                      <a:headEnd type="none" w="med" len="med"/>
+                      <a:tailEnd type="none" w="med" len="med"/>
+                    </a:lnL>
+                    <a:lnR w="6350" cap="flat" cmpd="sng" algn="ctr">
+                      <a:solidFill>
+                        <a:srgbClr val="1B2C4D"/>
+                      </a:solidFill>
+                      <a:prstDash val="solid"/>
+                      <a:round/>
+                      <a:headEnd type="none" w="med" len="med"/>
+                      <a:tailEnd type="none" w="med" len="med"/>
+                    </a:lnR>
+                    <a:lnT w="6350" cap="flat" cmpd="sng" algn="ctr">
+                      <a:solidFill>
+                        <a:srgbClr val="1B2C4D"/>
+                      </a:solidFill>
+                      <a:prstDash val="solid"/>
+                      <a:round/>
+                      <a:headEnd type="none" w="med" len="med"/>
+                      <a:tailEnd type="none" w="med" len="med"/>
+                    </a:lnT>
+                    <a:lnB w="6350" cap="flat" cmpd="sng" algn="ctr">
+                      <a:solidFill>
+                        <a:srgbClr val="1B2C4D"/>
+                      </a:solidFill>
+                      <a:prstDash val="solid"/>
+                      <a:round/>
+                      <a:headEnd type="none" w="med" len="med"/>
+                      <a:tailEnd type="none" w="med" len="med"/>
+                    </a:lnB>
+                    <a:solidFill>
+                      <a:srgbClr val="0E1829"/>
+                    </a:solidFill>
+                  </a:tcPr>
+                </a:tc>
+              </a:tr>
+              <a:tr h="566928">
+                <a:tc>
+                  <a:txBody>
+                    <a:bodyPr/>
+                    <a:lstStyle/>
+                    <a:p>
+                      <a:pPr indent="0" marL="0">
+                        <a:buNone/>
+                      </a:pPr>
+                      <a:r>
+                        <a:rPr lang="en-US" sz="1350" dirty="0">
+                          <a:solidFill>
+                            <a:srgbClr val="E2E8F0"/>
+                          </a:solidFill>
+                          <a:latin typeface="Segoe UI" pitchFamily="34" charset="0"/>
+                          <a:ea typeface="Segoe UI" pitchFamily="34" charset="-122"/>
+                          <a:cs typeface="Segoe UI" pitchFamily="34" charset="-120"/>
+                        </a:rPr>
+                        <a:t>Vol-targeted variant (20% vol target)</a:t>
+                      </a:r>
+                      <a:endParaRPr lang="en-US" sz="1350" dirty="0">
+                        <a:latin typeface="Segoe UI" charset="0"/>
+                        <a:ea typeface="Segoe UI" charset="0"/>
+                        <a:cs typeface="Segoe UI" charset="0"/>
+                      </a:endParaRPr>
+                    </a:p>
+                  </a:txBody>
+                  <a:tcPr marL="91440" marR="91440" marT="45720" marB="45720" anchor="ctr">
+                    <a:lnL w="6350" cap="flat" cmpd="sng" algn="ctr">
+                      <a:solidFill>
+                        <a:srgbClr val="1B2C4D"/>
+                      </a:solidFill>
+                      <a:prstDash val="solid"/>
+                      <a:round/>
+                      <a:headEnd type="none" w="med" len="med"/>
+                      <a:tailEnd type="none" w="med" len="med"/>
+                    </a:lnL>
+                    <a:lnR w="6350" cap="flat" cmpd="sng" algn="ctr">
+                      <a:solidFill>
+                        <a:srgbClr val="1B2C4D"/>
+                      </a:solidFill>
+                      <a:prstDash val="solid"/>
+                      <a:round/>
+                      <a:headEnd type="none" w="med" len="med"/>
+                      <a:tailEnd type="none" w="med" len="med"/>
+                    </a:lnR>
+                    <a:lnT w="6350" cap="flat" cmpd="sng" algn="ctr">
+                      <a:solidFill>
+                        <a:srgbClr val="1B2C4D"/>
+                      </a:solidFill>
+                      <a:prstDash val="solid"/>
+                      <a:round/>
+                      <a:headEnd type="none" w="med" len="med"/>
+                      <a:tailEnd type="none" w="med" len="med"/>
+                    </a:lnT>
+                    <a:lnB w="6350" cap="flat" cmpd="sng" algn="ctr">
+                      <a:solidFill>
+                        <a:srgbClr val="1B2C4D"/>
+                      </a:solidFill>
+                      <a:prstDash val="solid"/>
+                      <a:round/>
+                      <a:headEnd type="none" w="med" len="med"/>
+                      <a:tailEnd type="none" w="med" len="med"/>
+                    </a:lnB>
+                    <a:solidFill>
+                      <a:srgbClr val="0E1829"/>
+                    </a:solidFill>
+                  </a:tcPr>
+                </a:tc>
+                <a:tc>
+                  <a:txBody>
+                    <a:bodyPr/>
+                    <a:lstStyle/>
+                    <a:p>
+                      <a:pPr algn="r" indent="0" marL="0">
+                        <a:buNone/>
+                      </a:pPr>
+                      <a:r>
+                        <a:rPr lang="en-US" sz="1500" b="1" dirty="0">
+                          <a:solidFill>
+                            <a:srgbClr val="2DD4BF"/>
+                          </a:solidFill>
+                          <a:latin typeface="Segoe UI" pitchFamily="34" charset="0"/>
+                          <a:ea typeface="Segoe UI" pitchFamily="34" charset="-122"/>
+                          <a:cs typeface="Segoe UI" pitchFamily="34" charset="-120"/>
+                        </a:rPr>
+                        <a:t>-10.4%</a:t>
+                      </a:r>
+                      <a:endParaRPr lang="en-US" sz="1500" dirty="0">
+                        <a:latin typeface="Segoe UI" charset="0"/>
+                        <a:ea typeface="Segoe UI" charset="0"/>
+                        <a:cs typeface="Segoe UI" charset="0"/>
+                      </a:endParaRPr>
+                    </a:p>
+                  </a:txBody>
+                  <a:tcPr marL="91440" marR="91440" marT="45720" marB="45720" anchor="ctr">
+                    <a:lnL w="6350" cap="flat" cmpd="sng" algn="ctr">
+                      <a:solidFill>
+                        <a:srgbClr val="1B2C4D"/>
+                      </a:solidFill>
+                      <a:prstDash val="solid"/>
+                      <a:round/>
+                      <a:headEnd type="none" w="med" len="med"/>
+                      <a:tailEnd type="none" w="med" len="med"/>
+                    </a:lnL>
+                    <a:lnR w="6350" cap="flat" cmpd="sng" algn="ctr">
+                      <a:solidFill>
+                        <a:srgbClr val="1B2C4D"/>
+                      </a:solidFill>
+                      <a:prstDash val="solid"/>
+                      <a:round/>
+                      <a:headEnd type="none" w="med" len="med"/>
+                      <a:tailEnd type="none" w="med" len="med"/>
+                    </a:lnR>
+                    <a:lnT w="6350" cap="flat" cmpd="sng" algn="ctr">
+                      <a:solidFill>
+                        <a:srgbClr val="1B2C4D"/>
+                      </a:solidFill>
+                      <a:prstDash val="solid"/>
+                      <a:round/>
+                      <a:headEnd type="none" w="med" len="med"/>
+                      <a:tailEnd type="none" w="med" len="med"/>
+                    </a:lnT>
+                    <a:lnB w="6350" cap="flat" cmpd="sng" algn="ctr">
+                      <a:solidFill>
+                        <a:srgbClr val="1B2C4D"/>
+                      </a:solidFill>
+                      <a:prstDash val="solid"/>
+                      <a:round/>
+                      <a:headEnd type="none" w="med" len="med"/>
+                      <a:tailEnd type="none" w="med" len="med"/>
+                    </a:lnB>
+                    <a:solidFill>
+                      <a:srgbClr val="0E1829"/>
+                    </a:solidFill>
+                  </a:tcPr>
+                </a:tc>
+                <a:tc>
+                  <a:txBody>
+                    <a:bodyPr/>
+                    <a:lstStyle/>
+                    <a:p>
+                      <a:pPr indent="0" marL="0">
+                        <a:buNone/>
+                      </a:pPr>
+                      <a:r>
+                        <a:rPr lang="en-US" sz="1100" dirty="0">
+                          <a:solidFill>
+                            <a:srgbClr val="94A3B8"/>
+                          </a:solidFill>
+                          <a:latin typeface="Segoe UI" pitchFamily="34" charset="0"/>
+                          <a:ea typeface="Segoe UI" pitchFamily="34" charset="-122"/>
+                          <a:cs typeface="Segoe UI" pitchFamily="34" charset="-120"/>
+                        </a:rPr>
+                        <a:t>vs -22.7% benchmark; realized vol 20.7%</a:t>
                       </a:r>
                       <a:endParaRPr lang="en-US" sz="1100" dirty="0">
                         <a:latin typeface="Segoe UI" charset="0"/>
@@ -5435,7 +5641,28 @@
                 <a:ea typeface="Segoe UI" pitchFamily="34" charset="-122"/>
                 <a:cs typeface="Segoe UI" pitchFamily="34" charset="-120"/>
               </a:rPr>
-              <a:t>We report the losing configurations too (turnover study) - measured, not marketed.</a:t>
+              <a:t>We report the losing configurations too (turnover regime study) - measured, not marketed.</a:t>
+            </a:r>
+            <a:endParaRPr lang="en-US" sz="1200" dirty="0"/>
+          </a:p>
+          <a:p>
+            <a:pPr marL="127000" indent="-127000">
+              <a:spcAft>
+                <a:spcPts val="1000"/>
+              </a:spcAft>
+              <a:buSzPct val="100000"/>
+              <a:buChar char="•"/>
+            </a:pPr>
+            <a:r>
+              <a:rPr lang="en-US" sz="1200" dirty="0">
+                <a:solidFill>
+                  <a:srgbClr val="E2E8F0"/>
+                </a:solidFill>
+                <a:latin typeface="Segoe UI" pitchFamily="34" charset="0"/>
+                <a:ea typeface="Segoe UI" pitchFamily="34" charset="-122"/>
+                <a:cs typeface="Segoe UI" pitchFamily="34" charset="-120"/>
+              </a:rPr>
+              <a:t>Loan-book credit parameters calibrated from 1.35M real Lending Club loans.</a:t>
             </a:r>
             <a:endParaRPr lang="en-US" sz="1200" dirty="0"/>
           </a:p>
@@ -6099,7 +6326,7 @@
           <a:ln/>
         </p:spPr>
         <p:txBody>
-          <a:bodyPr wrap="square" lIns="0" tIns="0" rIns="0" bIns="0" rtlCol="0" anchor="ctr"/>
+          <a:bodyPr wrap="square" lIns="0" tIns="0" rIns="0" bIns="0" rtlCol="0" anchor="t"/>
           <a:lstStyle/>
           <a:p>
             <a:pPr marL="127000" indent="-127000">
@@ -6160,7 +6387,7 @@
                 <a:ea typeface="Segoe UI" pitchFamily="34" charset="-122"/>
                 <a:cs typeface="Segoe UI" pitchFamily="34" charset="-120"/>
               </a:rPr>
-              <a:t>Impact IC of 0.066 is modest by design: daily-horizon news signals live in the 0.5-2% R2 zone.</a:t>
+              <a:t>Impact IC of 0.065 is modest by design: daily-horizon news signals live in the 0.5-2% R2 zone.</a:t>
             </a:r>
             <a:endParaRPr lang="en-US" sz="1300" dirty="0"/>
           </a:p>
@@ -6271,7 +6498,7 @@
           <a:ln/>
         </p:spPr>
         <p:txBody>
-          <a:bodyPr wrap="square" lIns="0" tIns="0" rIns="0" bIns="0" rtlCol="0" anchor="ctr"/>
+          <a:bodyPr wrap="square" lIns="0" tIns="0" rIns="0" bIns="0" rtlCol="0" anchor="t"/>
           <a:lstStyle/>
           <a:p>
             <a:pPr marL="127000" indent="-127000">

</xml_diff>